<commit_message>
Fix factual errors found in final review
- Awaji case: provider is NTT TownPage (partner), not docomo BS
- NTT docomo Business Solutions former name corrected in notes
- RESAS: mobaku supplies stay-population data, not all population data
- Ishikawa criteria: largest weight is planning; reworded takeaway
- LINE reach updated to official 98M figure; unverified Yahoo figure removed
- Premier Panel: base fee covers up to 15 questions (max 20)
- Mesh size wording, proposal section label, panel wording

Co-Authored-By: Claude Opus 5.5 <noreply@anthropic.com>
Claude-Session: https://claude.ai/code/session_0122wdri1Yhz7WwnvnusACaQ
</commit_message>
<xml_diff>
--- a/docs/sales/docomo_3商材_チーム営業提案_改訂版.pptx
+++ b/docs/sales/docomo_3商材_チーム営業提案_改訂版.pptx
@@ -1026,7 +1026,7 @@
           <a:p>
             <a:r>
               <a:rPr lang="en-US" dirty="0"/>
-              <a:t>人口マップの月額9万円〜はトップページ掲載。税区分・初期費用・最低期間は当該記載から断定しない。標準版とは別メニュー。プレミアパネルは最低275,000円税込、最大20問、回収数は目標。アンケート設計165,000円、簡易レポート165,000円〜等の追加費用。広告の最低出稿額は参照した公式ページに掲載なし。
+              <a:t>人口マップの月額9万円〜はトップページ掲載。税区分・初期費用・最低期間は当該記載から断定しない。標準版とは別メニュー。プレミアパネルは最低275,000円税込、基本15問まで（1問追加ごとに22,000円税込、最大20問）、回収数は目標。アンケート設計165,000円、簡易レポート165,000円〜等の追加費用。広告の最低出稿額は参照した公式ページに掲載なし。
 ※検索では「最低275,000円（税込）」がプロモーションサービス側の料金として表示された。リサーチの料金はサンプル数・設問数で決まる旨の案内もあるため、正式見積で確認する。広告は2026年7月以降CARTA ZEROが窓口。
 出典（2026年9月25日確認、※は9月27日追加確認）
 https://mobaku.jp/
@@ -7295,7 +7295,7 @@
                 <a:ea typeface="Meiryo" pitchFamily="34" charset="-122"/>
                 <a:cs typeface="Meiryo" pitchFamily="34" charset="-120"/>
               </a:rPr>
-              <a:t>税込・最大20問・回収数は目標</a:t>
+              <a:t>税込・15問まで（最大20問）・回収数は目標</a:t>
             </a:r>
             <a:endParaRPr lang="en-US" sz="1100" dirty="0"/>
           </a:p>

</xml_diff>